<commit_message>
Flaecheninhalt: 12 Formen und 12 Formeln, eindeutig 1:1 benannt
Co-Authored-By: Claude Sonnet 5.5 <noreply@anthropic.com>
Claude-Session: https://claude.ai/code/session_0139kriXJ67p3UvpR2gsSR9G
</commit_message>
<xml_diff>
--- a/videoslides/flaecheninhalt-formeln.pptx
+++ b/videoslides/flaecheninhalt-formeln.pptx
@@ -16,9 +16,10 @@
     <p:sldId id="264" r:id="rId10"/>
     <p:sldId id="265" r:id="rId11"/>
     <p:sldId id="266" r:id="rId12"/>
+    <p:sldId id="267" r:id="rId13"/>
   </p:sldIdLst>
   <p:notesMasterIdLst>
-    <p:notesMasterId r:id="rId13"/>
+    <p:notesMasterId r:id="rId14"/>
   </p:notesMasterIdLst>
   <p:sldSz cx="12192000" cy="6858000"/>
   <p:notesSz cx="6858000" cy="12192000"/>
@@ -512,7 +513,7 @@
           <a:p>
             <a:r>
               <a:rPr lang="en-US" dirty="0"/>
-              <a:t>Rechteck</a:t>
+              <a:t>Formel 01: Rechteck</a:t>
             </a:r>
             <a:endParaRPr lang="en-US" dirty="0"/>
           </a:p>
@@ -600,7 +601,7 @@
           <a:p>
             <a:r>
               <a:rPr lang="en-US" dirty="0"/>
-              <a:t>Allgemeines Dreieck (a)</a:t>
+              <a:t>Formel 10: Allgemeines Dreieck (Grundseite c)</a:t>
             </a:r>
             <a:endParaRPr lang="en-US" dirty="0"/>
           </a:p>
@@ -688,7 +689,7 @@
           <a:p>
             <a:r>
               <a:rPr lang="en-US" dirty="0"/>
-              <a:t>Allgemeines Dreieck (b)</a:t>
+              <a:t>Formel 11: Allgemeines Dreieck (Grundseite a)</a:t>
             </a:r>
             <a:endParaRPr lang="en-US" dirty="0"/>
           </a:p>
@@ -712,6 +713,94 @@
             <a:fld id="{F7021451-1387-4CA6-816F-3879F97B5CBC}" type="slidenum">
               <a:rPr lang="en-US"/>
               <a:t>11</a:t>
+            </a:fld>
+            <a:endParaRPr lang="en-US"/>
+          </a:p>
+        </p:txBody>
+      </p:sp>
+    </p:spTree>
+    <p:extLst>
+      <p:ext uri="{BB962C8B-B14F-4D97-AF65-F5344CB8AC3E}">
+        <p14:creationId xmlns:p14="http://schemas.microsoft.com/office/powerpoint/2010/main" val="1024086991"/>
+      </p:ext>
+    </p:extLst>
+  </p:cSld>
+  <p:clrMapOvr>
+    <a:masterClrMapping/>
+  </p:clrMapOvr>
+</p:notes>
+</file>
+
+<file path=ppt/notesSlides/notesSlide12.xml><?xml version="1.0" encoding="utf-8"?>
+<p:notes xmlns:a="http://schemas.openxmlformats.org/drawingml/2006/main" xmlns:r="http://schemas.openxmlformats.org/officeDocument/2006/relationships" xmlns:p="http://schemas.openxmlformats.org/presentationml/2006/main">
+  <p:cSld>
+    <p:spTree>
+      <p:nvGrpSpPr>
+        <p:cNvPr id="1" name=""/>
+        <p:cNvGrpSpPr/>
+        <p:nvPr/>
+      </p:nvGrpSpPr>
+      <p:grpSpPr>
+        <a:xfrm>
+          <a:off x="0" y="0"/>
+          <a:ext cx="0" cy="0"/>
+          <a:chOff x="0" y="0"/>
+          <a:chExt cx="0" cy="0"/>
+        </a:xfrm>
+      </p:grpSpPr>
+      <p:sp>
+        <p:nvSpPr>
+          <p:cNvPr id="2" name="Slide Image Placeholder 1"/>
+          <p:cNvSpPr>
+            <a:spLocks noGrp="1" noRot="1" noChangeAspect="1"/>
+          </p:cNvSpPr>
+          <p:nvPr>
+            <p:ph type="sldImg"/>
+          </p:nvPr>
+        </p:nvSpPr>
+        <p:spPr/>
+      </p:sp>
+      <p:sp>
+        <p:nvSpPr>
+          <p:cNvPr id="3" name="Notes Placeholder 2"/>
+          <p:cNvSpPr>
+            <a:spLocks noGrp="1"/>
+          </p:cNvSpPr>
+          <p:nvPr>
+            <p:ph type="body" idx="1"/>
+          </p:nvPr>
+        </p:nvSpPr>
+        <p:spPr/>
+        <p:txBody>
+          <a:bodyPr/>
+          <a:lstStyle/>
+          <a:p>
+            <a:r>
+              <a:rPr lang="en-US" dirty="0"/>
+              <a:t>Formel 12: Allgemeines Dreieck (Grundseite b)</a:t>
+            </a:r>
+            <a:endParaRPr lang="en-US" dirty="0"/>
+          </a:p>
+        </p:txBody>
+      </p:sp>
+      <p:sp>
+        <p:nvSpPr>
+          <p:cNvPr id="4" name="Slide Number Placeholder 3"/>
+          <p:cNvSpPr>
+            <a:spLocks noGrp="1"/>
+          </p:cNvSpPr>
+          <p:nvPr>
+            <p:ph type="sldNum" sz="quarter" idx="10"/>
+          </p:nvPr>
+        </p:nvSpPr>
+        <p:spPr/>
+        <p:txBody>
+          <a:bodyPr/>
+          <a:lstStyle/>
+          <a:p>
+            <a:fld id="{F7021451-1387-4CA6-816F-3879F97B5CBC}" type="slidenum">
+              <a:rPr lang="en-US"/>
+              <a:t>12</a:t>
             </a:fld>
             <a:endParaRPr lang="en-US"/>
           </a:p>
@@ -776,7 +865,7 @@
           <a:p>
             <a:r>
               <a:rPr lang="en-US" dirty="0"/>
-              <a:t>Quadrat</a:t>
+              <a:t>Formel 02: Quadrat</a:t>
             </a:r>
             <a:endParaRPr lang="en-US" dirty="0"/>
           </a:p>
@@ -864,7 +953,7 @@
           <a:p>
             <a:r>
               <a:rPr lang="en-US" dirty="0"/>
-              <a:t>Rechtwinkliges Dreieck</a:t>
+              <a:t>Formel 03: Rechtwinkliges Dreieck</a:t>
             </a:r>
             <a:endParaRPr lang="en-US" dirty="0"/>
           </a:p>
@@ -952,7 +1041,7 @@
           <a:p>
             <a:r>
               <a:rPr lang="en-US" dirty="0"/>
-              <a:t>Parallelogramm (a)</a:t>
+              <a:t>Formel 04: Parallelogramm (Grundseite a)</a:t>
             </a:r>
             <a:endParaRPr lang="en-US" dirty="0"/>
           </a:p>
@@ -1040,7 +1129,7 @@
           <a:p>
             <a:r>
               <a:rPr lang="en-US" dirty="0"/>
-              <a:t>Parallelogramm (b)</a:t>
+              <a:t>Formel 05: Parallelogramm (Grundseite b)</a:t>
             </a:r>
             <a:endParaRPr lang="en-US" dirty="0"/>
           </a:p>
@@ -1128,7 +1217,7 @@
           <a:p>
             <a:r>
               <a:rPr lang="en-US" dirty="0"/>
-              <a:t>Raute (a · h)</a:t>
+              <a:t>Formel 06: Raute (Seite a, Höhe h)</a:t>
             </a:r>
             <a:endParaRPr lang="en-US" dirty="0"/>
           </a:p>
@@ -1216,7 +1305,7 @@
           <a:p>
             <a:r>
               <a:rPr lang="en-US" dirty="0"/>
-              <a:t>Raute / Deltoid</a:t>
+              <a:t>Formel 07: Raute (Diagonalen e, f)</a:t>
             </a:r>
             <a:endParaRPr lang="en-US" dirty="0"/>
           </a:p>
@@ -1304,7 +1393,7 @@
           <a:p>
             <a:r>
               <a:rPr lang="en-US" dirty="0"/>
-              <a:t>Trapez</a:t>
+              <a:t>Formel 08: Trapez</a:t>
             </a:r>
             <a:endParaRPr lang="en-US" dirty="0"/>
           </a:p>
@@ -1392,7 +1481,7 @@
           <a:p>
             <a:r>
               <a:rPr lang="en-US" dirty="0"/>
-              <a:t>Allgemeines Dreieck (c)</a:t>
+              <a:t>Formel 09: Deltoid</a:t>
             </a:r>
             <a:endParaRPr lang="en-US" dirty="0"/>
           </a:p>
@@ -1794,7 +1883,7 @@
       </p:sp>
       <p:sp>
         <p:nvSpPr>
-          <p:cNvPr id="4" name="Formel Rechteck"/>
+          <p:cNvPr id="4" name="Formel 01 Rechteck"/>
           <p:cNvSpPr txBox="1"/>
           <p:nvPr/>
         </p:nvSpPr>
@@ -1871,8 +1960,8 @@
         </p:nvSpPr>
         <p:spPr>
           <a:xfrm>
-            <a:off x="2914650" y="2552700"/>
-            <a:ext cx="6362700" cy="1752600"/>
+            <a:off x="2907030" y="2552700"/>
+            <a:ext cx="6377940" cy="1752600"/>
           </a:xfrm>
           <a:prstGeom prst="roundRect">
             <a:avLst>
@@ -1892,14 +1981,14 @@
       </p:sp>
       <p:sp>
         <p:nvSpPr>
-          <p:cNvPr id="4" name="Formel Allgemeines Dreieck (a)"/>
+          <p:cNvPr id="4" name="Formel 10 Allgemeines Dreieck (Grundseite c)"/>
           <p:cNvSpPr txBox="1"/>
           <p:nvPr/>
         </p:nvSpPr>
         <p:spPr>
           <a:xfrm>
-            <a:off x="2914650" y="2552700"/>
-            <a:ext cx="6362700" cy="1752600"/>
+            <a:off x="2907030" y="2552700"/>
+            <a:ext cx="6377940" cy="1752600"/>
           </a:xfrm>
           <a:prstGeom prst="rect">
             <a:avLst/>
@@ -1923,7 +2012,7 @@
                 <a:ea typeface="Poppins" pitchFamily="34" charset="-122"/>
                 <a:cs typeface="Poppins" pitchFamily="34" charset="-120"/>
               </a:rPr>
-              <a:t>A = a · </a:t>
+              <a:t>A = c · </a:t>
             </a:r>
             <a:pPr algn="ctr" indent="0" marL="0">
               <a:buNone/>
@@ -1951,7 +2040,7 @@
                 <a:ea typeface="Poppins" pitchFamily="34" charset="-122"/>
                 <a:cs typeface="Poppins" pitchFamily="34" charset="-120"/>
               </a:rPr>
-              <a:t>a</a:t>
+              <a:t>c</a:t>
             </a:r>
             <a:pPr algn="ctr" indent="0" marL="0">
               <a:buNone/>
@@ -2011,6 +2100,146 @@
         </p:nvSpPr>
         <p:spPr>
           <a:xfrm>
+            <a:off x="2914650" y="2552700"/>
+            <a:ext cx="6362700" cy="1752600"/>
+          </a:xfrm>
+          <a:prstGeom prst="roundRect">
+            <a:avLst>
+              <a:gd name="adj" fmla="val 15652"/>
+            </a:avLst>
+          </a:prstGeom>
+          <a:solidFill>
+            <a:srgbClr val="0F2A52"/>
+          </a:solidFill>
+          <a:ln w="12700">
+            <a:solidFill>
+              <a:srgbClr val="0F2A52"/>
+            </a:solidFill>
+            <a:prstDash val="solid"/>
+          </a:ln>
+        </p:spPr>
+      </p:sp>
+      <p:sp>
+        <p:nvSpPr>
+          <p:cNvPr id="4" name="Formel 11 Allgemeines Dreieck (Grundseite a)"/>
+          <p:cNvSpPr txBox="1"/>
+          <p:nvPr/>
+        </p:nvSpPr>
+        <p:spPr>
+          <a:xfrm>
+            <a:off x="2914650" y="2552700"/>
+            <a:ext cx="6362700" cy="1752600"/>
+          </a:xfrm>
+          <a:prstGeom prst="rect">
+            <a:avLst/>
+          </a:prstGeom>
+          <a:noFill/>
+          <a:ln/>
+        </p:spPr>
+        <p:txBody>
+          <a:bodyPr wrap="square" lIns="0" tIns="0" rIns="0" bIns="0" rtlCol="0" anchor="ctr"/>
+          <a:lstStyle/>
+          <a:p>
+            <a:pPr algn="ctr" indent="0" marL="0">
+              <a:buNone/>
+            </a:pPr>
+            <a:r>
+              <a:rPr lang="en-US" sz="6500" b="1" dirty="0">
+                <a:solidFill>
+                  <a:srgbClr val="8DBBF2"/>
+                </a:solidFill>
+                <a:latin typeface="Poppins" pitchFamily="34" charset="0"/>
+                <a:ea typeface="Poppins" pitchFamily="34" charset="-122"/>
+                <a:cs typeface="Poppins" pitchFamily="34" charset="-120"/>
+              </a:rPr>
+              <a:t>A = a · </a:t>
+            </a:r>
+            <a:pPr algn="ctr" indent="0" marL="0">
+              <a:buNone/>
+            </a:pPr>
+            <a:r>
+              <a:rPr lang="en-US" sz="6500" b="1" dirty="0">
+                <a:solidFill>
+                  <a:srgbClr val="8DBBF2"/>
+                </a:solidFill>
+                <a:latin typeface="Poppins" pitchFamily="34" charset="0"/>
+                <a:ea typeface="Poppins" pitchFamily="34" charset="-122"/>
+                <a:cs typeface="Poppins" pitchFamily="34" charset="-120"/>
+              </a:rPr>
+              <a:t>h</a:t>
+            </a:r>
+            <a:pPr algn="ctr" indent="0" marL="0">
+              <a:buNone/>
+            </a:pPr>
+            <a:r>
+              <a:rPr lang="en-US" sz="6500" b="1" baseline="-40000" dirty="0">
+                <a:solidFill>
+                  <a:srgbClr val="8DBBF2"/>
+                </a:solidFill>
+                <a:latin typeface="Poppins" pitchFamily="34" charset="0"/>
+                <a:ea typeface="Poppins" pitchFamily="34" charset="-122"/>
+                <a:cs typeface="Poppins" pitchFamily="34" charset="-120"/>
+              </a:rPr>
+              <a:t>a</a:t>
+            </a:r>
+            <a:pPr algn="ctr" indent="0" marL="0">
+              <a:buNone/>
+            </a:pPr>
+            <a:r>
+              <a:rPr lang="en-US" sz="6500" b="1" dirty="0">
+                <a:solidFill>
+                  <a:srgbClr val="8DBBF2"/>
+                </a:solidFill>
+                <a:latin typeface="Poppins" pitchFamily="34" charset="0"/>
+                <a:ea typeface="Poppins" pitchFamily="34" charset="-122"/>
+                <a:cs typeface="Poppins" pitchFamily="34" charset="-120"/>
+              </a:rPr>
+              <a:t> : 2</a:t>
+            </a:r>
+            <a:endParaRPr lang="en-US" sz="6500" dirty="0"/>
+          </a:p>
+        </p:txBody>
+      </p:sp>
+    </p:spTree>
+  </p:cSld>
+  <p:clrMapOvr>
+    <a:masterClrMapping/>
+  </p:clrMapOvr>
+</p:sld>
+</file>
+
+<file path=ppt/slides/slide12.xml><?xml version="1.0" encoding="utf-8"?>
+<p:sld xmlns:a="http://schemas.openxmlformats.org/drawingml/2006/main" xmlns:r="http://schemas.openxmlformats.org/officeDocument/2006/relationships" xmlns:p="http://schemas.openxmlformats.org/presentationml/2006/main">
+  <p:cSld name="Slide 12">
+    <p:bg>
+      <p:bgPr>
+        <a:solidFill>
+          <a:srgbClr val="DCEBFA"/>
+        </a:solidFill>
+      </p:bgPr>
+    </p:bg>
+    <p:spTree>
+      <p:nvGrpSpPr>
+        <p:cNvPr id="1" name=""/>
+        <p:cNvGrpSpPr/>
+        <p:nvPr/>
+      </p:nvGrpSpPr>
+      <p:grpSpPr>
+        <a:xfrm>
+          <a:off x="0" y="0"/>
+          <a:ext cx="0" cy="0"/>
+          <a:chOff x="0" y="0"/>
+          <a:chExt cx="0" cy="0"/>
+        </a:xfrm>
+      </p:grpSpPr>
+      <p:sp>
+        <p:nvSpPr>
+          <p:cNvPr id="3" name="Formel-Fläche"/>
+          <p:cNvSpPr/>
+          <p:nvPr/>
+        </p:nvSpPr>
+        <p:spPr>
+          <a:xfrm>
             <a:off x="2876550" y="2552700"/>
             <a:ext cx="6438900" cy="1752600"/>
           </a:xfrm>
@@ -2032,7 +2261,7 @@
       </p:sp>
       <p:sp>
         <p:nvSpPr>
-          <p:cNvPr id="4" name="Formel Allgemeines Dreieck (b)"/>
+          <p:cNvPr id="4" name="Formel 12 Allgemeines Dreieck (Grundseite b)"/>
           <p:cNvSpPr txBox="1"/>
           <p:nvPr/>
         </p:nvSpPr>
@@ -2172,7 +2401,7 @@
       </p:sp>
       <p:sp>
         <p:nvSpPr>
-          <p:cNvPr id="4" name="Formel Quadrat"/>
+          <p:cNvPr id="4" name="Formel 02 Quadrat"/>
           <p:cNvSpPr txBox="1"/>
           <p:nvPr/>
         </p:nvSpPr>
@@ -2270,7 +2499,7 @@
       </p:sp>
       <p:sp>
         <p:nvSpPr>
-          <p:cNvPr id="4" name="Formel Rechtwinkliges Dreieck"/>
+          <p:cNvPr id="4" name="Formel 03 Rechtwinkliges Dreieck"/>
           <p:cNvSpPr txBox="1"/>
           <p:nvPr/>
         </p:nvSpPr>
@@ -2368,7 +2597,7 @@
       </p:sp>
       <p:sp>
         <p:nvSpPr>
-          <p:cNvPr id="4" name="Formel Parallelogramm (a)"/>
+          <p:cNvPr id="4" name="Formel 04 Parallelogramm (Grundseite a)"/>
           <p:cNvSpPr txBox="1"/>
           <p:nvPr/>
         </p:nvSpPr>
@@ -2494,7 +2723,7 @@
       </p:sp>
       <p:sp>
         <p:nvSpPr>
-          <p:cNvPr id="4" name="Formel Parallelogramm (b)"/>
+          <p:cNvPr id="4" name="Formel 05 Parallelogramm (Grundseite b)"/>
           <p:cNvSpPr txBox="1"/>
           <p:nvPr/>
         </p:nvSpPr>
@@ -2620,7 +2849,7 @@
       </p:sp>
       <p:sp>
         <p:nvSpPr>
-          <p:cNvPr id="4" name="Formel Raute (a · h)"/>
+          <p:cNvPr id="4" name="Formel 06 Raute (Seite a, Höhe h)"/>
           <p:cNvSpPr txBox="1"/>
           <p:nvPr/>
         </p:nvSpPr>
@@ -2718,7 +2947,7 @@
       </p:sp>
       <p:sp>
         <p:nvSpPr>
-          <p:cNvPr id="4" name="Formel Raute / Deltoid"/>
+          <p:cNvPr id="4" name="Formel 07 Raute (Diagonalen e, f)"/>
           <p:cNvSpPr txBox="1"/>
           <p:nvPr/>
         </p:nvSpPr>
@@ -2816,7 +3045,7 @@
       </p:sp>
       <p:sp>
         <p:nvSpPr>
-          <p:cNvPr id="4" name="Formel Trapez"/>
+          <p:cNvPr id="4" name="Formel 08 Trapez"/>
           <p:cNvSpPr txBox="1"/>
           <p:nvPr/>
         </p:nvSpPr>
@@ -2893,8 +3122,8 @@
         </p:nvSpPr>
         <p:spPr>
           <a:xfrm>
-            <a:off x="2907030" y="2552700"/>
-            <a:ext cx="6377940" cy="1752600"/>
+            <a:off x="3177540" y="2552700"/>
+            <a:ext cx="5836920" cy="1752600"/>
           </a:xfrm>
           <a:prstGeom prst="roundRect">
             <a:avLst>
@@ -2914,14 +3143,14 @@
       </p:sp>
       <p:sp>
         <p:nvSpPr>
-          <p:cNvPr id="4" name="Formel Allgemeines Dreieck (c)"/>
+          <p:cNvPr id="4" name="Formel 09 Deltoid"/>
           <p:cNvSpPr txBox="1"/>
           <p:nvPr/>
         </p:nvSpPr>
         <p:spPr>
           <a:xfrm>
-            <a:off x="2907030" y="2552700"/>
-            <a:ext cx="6377940" cy="1752600"/>
+            <a:off x="3177540" y="2552700"/>
+            <a:ext cx="5836920" cy="1752600"/>
           </a:xfrm>
           <a:prstGeom prst="rect">
             <a:avLst/>
@@ -2945,49 +3174,7 @@
                 <a:ea typeface="Poppins" pitchFamily="34" charset="-122"/>
                 <a:cs typeface="Poppins" pitchFamily="34" charset="-120"/>
               </a:rPr>
-              <a:t>A = c · </a:t>
-            </a:r>
-            <a:pPr algn="ctr" indent="0" marL="0">
-              <a:buNone/>
-            </a:pPr>
-            <a:r>
-              <a:rPr lang="en-US" sz="6500" b="1" dirty="0">
-                <a:solidFill>
-                  <a:srgbClr val="8DBBF2"/>
-                </a:solidFill>
-                <a:latin typeface="Poppins" pitchFamily="34" charset="0"/>
-                <a:ea typeface="Poppins" pitchFamily="34" charset="-122"/>
-                <a:cs typeface="Poppins" pitchFamily="34" charset="-120"/>
-              </a:rPr>
-              <a:t>h</a:t>
-            </a:r>
-            <a:pPr algn="ctr" indent="0" marL="0">
-              <a:buNone/>
-            </a:pPr>
-            <a:r>
-              <a:rPr lang="en-US" sz="6500" b="1" baseline="-40000" dirty="0">
-                <a:solidFill>
-                  <a:srgbClr val="8DBBF2"/>
-                </a:solidFill>
-                <a:latin typeface="Poppins" pitchFamily="34" charset="0"/>
-                <a:ea typeface="Poppins" pitchFamily="34" charset="-122"/>
-                <a:cs typeface="Poppins" pitchFamily="34" charset="-120"/>
-              </a:rPr>
-              <a:t>c</a:t>
-            </a:r>
-            <a:pPr algn="ctr" indent="0" marL="0">
-              <a:buNone/>
-            </a:pPr>
-            <a:r>
-              <a:rPr lang="en-US" sz="6500" b="1" dirty="0">
-                <a:solidFill>
-                  <a:srgbClr val="8DBBF2"/>
-                </a:solidFill>
-                <a:latin typeface="Poppins" pitchFamily="34" charset="0"/>
-                <a:ea typeface="Poppins" pitchFamily="34" charset="-122"/>
-                <a:cs typeface="Poppins" pitchFamily="34" charset="-120"/>
-              </a:rPr>
-              <a:t> : 2</a:t>
+              <a:t>A = e · f : 2</a:t>
             </a:r>
             <a:endParaRPr lang="en-US" sz="6500" dirty="0"/>
           </a:p>

</xml_diff>

<commit_message>
Flaecheninhalt-Formeln mit Bruchstrich statt :2
Co-Authored-By: Claude Sonnet 5.5 <noreply@anthropic.com>
Claude-Session: https://claude.ai/code/session_0139kriXJ67p3UvpR2gsSR9G
</commit_message>
<xml_diff>
--- a/videoslides/flaecheninhalt-formeln.pptx
+++ b/videoslides/flaecheninhalt-formeln.pptx
@@ -1856,18 +1856,18 @@
       </p:grpSpPr>
       <p:sp>
         <p:nvSpPr>
-          <p:cNvPr id="3" name="Formel-Fläche"/>
+          <p:cNvPr id="3" name="Formel 01 Fläche Rechteck"/>
           <p:cNvSpPr/>
           <p:nvPr/>
         </p:nvSpPr>
         <p:spPr>
           <a:xfrm>
-            <a:off x="3733800" y="2552700"/>
-            <a:ext cx="4724400" cy="1752600"/>
+            <a:off x="3817620" y="2133600"/>
+            <a:ext cx="4556760" cy="2590800"/>
           </a:xfrm>
           <a:prstGeom prst="roundRect">
             <a:avLst>
-              <a:gd name="adj" fmla="val 15652"/>
+              <a:gd name="adj" fmla="val 12353"/>
             </a:avLst>
           </a:prstGeom>
           <a:solidFill>
@@ -1883,14 +1883,14 @@
       </p:sp>
       <p:sp>
         <p:nvSpPr>
-          <p:cNvPr id="4" name="Formel 01 Rechteck"/>
+          <p:cNvPr id="4" name="Formel 01 Text 1"/>
           <p:cNvSpPr txBox="1"/>
           <p:nvPr/>
         </p:nvSpPr>
         <p:spPr>
           <a:xfrm>
-            <a:off x="3733800" y="2552700"/>
-            <a:ext cx="4724400" cy="1752600"/>
+            <a:off x="4381500" y="2895600"/>
+            <a:ext cx="3435191" cy="1066800"/>
           </a:xfrm>
           <a:prstGeom prst="rect">
             <a:avLst/>
@@ -1899,14 +1899,14 @@
           <a:ln/>
         </p:spPr>
         <p:txBody>
-          <a:bodyPr wrap="square" lIns="0" tIns="0" rIns="0" bIns="0" rtlCol="0" anchor="ctr"/>
+          <a:bodyPr wrap="none" lIns="0" tIns="0" rIns="0" bIns="0" rtlCol="0" anchor="ctr"/>
           <a:lstStyle/>
           <a:p>
             <a:pPr algn="ctr" indent="0" marL="0">
               <a:buNone/>
             </a:pPr>
             <a:r>
-              <a:rPr lang="en-US" sz="6500" b="1" dirty="0">
+              <a:rPr lang="en-US" sz="6000" b="1" dirty="0">
                 <a:solidFill>
                   <a:srgbClr val="8DBBF2"/>
                 </a:solidFill>
@@ -1914,9 +1914,23 @@
                 <a:ea typeface="Poppins" pitchFamily="34" charset="-122"/>
                 <a:cs typeface="Poppins" pitchFamily="34" charset="-120"/>
               </a:rPr>
-              <a:t>A = a · b</a:t>
-            </a:r>
-            <a:endParaRPr lang="en-US" sz="6500" dirty="0"/>
+              <a:t>A = </a:t>
+            </a:r>
+            <a:pPr algn="ctr" indent="0" marL="0">
+              <a:buNone/>
+            </a:pPr>
+            <a:r>
+              <a:rPr lang="en-US" sz="6000" b="1" dirty="0">
+                <a:solidFill>
+                  <a:srgbClr val="8DBBF2"/>
+                </a:solidFill>
+                <a:latin typeface="Poppins" pitchFamily="34" charset="0"/>
+                <a:ea typeface="Poppins" pitchFamily="34" charset="-122"/>
+                <a:cs typeface="Poppins" pitchFamily="34" charset="-120"/>
+              </a:rPr>
+              <a:t>a · b</a:t>
+            </a:r>
+            <a:endParaRPr lang="en-US" sz="6000" dirty="0"/>
           </a:p>
         </p:txBody>
       </p:sp>
@@ -1954,18 +1968,18 @@
       </p:grpSpPr>
       <p:sp>
         <p:nvSpPr>
-          <p:cNvPr id="3" name="Formel-Fläche"/>
+          <p:cNvPr id="3" name="Formel 10 Fläche Allgemeines Dreieck (Grundseite c)"/>
           <p:cNvSpPr/>
           <p:nvPr/>
         </p:nvSpPr>
         <p:spPr>
           <a:xfrm>
-            <a:off x="2907030" y="2552700"/>
-            <a:ext cx="6377940" cy="1752600"/>
+            <a:off x="3467100" y="2133600"/>
+            <a:ext cx="5257800" cy="2590800"/>
           </a:xfrm>
           <a:prstGeom prst="roundRect">
             <a:avLst>
-              <a:gd name="adj" fmla="val 15652"/>
+              <a:gd name="adj" fmla="val 12353"/>
             </a:avLst>
           </a:prstGeom>
           <a:solidFill>
@@ -1981,14 +1995,14 @@
       </p:sp>
       <p:sp>
         <p:nvSpPr>
-          <p:cNvPr id="4" name="Formel 10 Allgemeines Dreieck (Grundseite c)"/>
+          <p:cNvPr id="4" name="Formel 10 Text 1"/>
           <p:cNvSpPr txBox="1"/>
           <p:nvPr/>
         </p:nvSpPr>
         <p:spPr>
           <a:xfrm>
-            <a:off x="2907030" y="2552700"/>
-            <a:ext cx="6377940" cy="1752600"/>
+            <a:off x="4030980" y="2895600"/>
+            <a:ext cx="1712238" cy="1066800"/>
           </a:xfrm>
           <a:prstGeom prst="rect">
             <a:avLst/>
@@ -1997,14 +2011,14 @@
           <a:ln/>
         </p:spPr>
         <p:txBody>
-          <a:bodyPr wrap="square" lIns="0" tIns="0" rIns="0" bIns="0" rtlCol="0" anchor="ctr"/>
+          <a:bodyPr wrap="none" lIns="0" tIns="0" rIns="0" bIns="0" rtlCol="0" anchor="ctr"/>
           <a:lstStyle/>
           <a:p>
             <a:pPr algn="ctr" indent="0" marL="0">
               <a:buNone/>
             </a:pPr>
             <a:r>
-              <a:rPr lang="en-US" sz="6500" b="1" dirty="0">
+              <a:rPr lang="en-US" sz="6000" b="1" dirty="0">
                 <a:solidFill>
                   <a:srgbClr val="8DBBF2"/>
                 </a:solidFill>
@@ -2012,13 +2026,52 @@
                 <a:ea typeface="Poppins" pitchFamily="34" charset="-122"/>
                 <a:cs typeface="Poppins" pitchFamily="34" charset="-120"/>
               </a:rPr>
-              <a:t>A = c · </a:t>
-            </a:r>
+              <a:t>A = </a:t>
+            </a:r>
+            <a:endParaRPr lang="en-US" sz="6000" dirty="0"/>
+          </a:p>
+        </p:txBody>
+      </p:sp>
+      <p:sp>
+        <p:nvSpPr>
+          <p:cNvPr id="5" name="Formel 10 Text 2"/>
+          <p:cNvSpPr txBox="1"/>
+          <p:nvPr/>
+        </p:nvSpPr>
+        <p:spPr>
+          <a:xfrm>
+            <a:off x="5842278" y="2392680"/>
+            <a:ext cx="2128242" cy="1066800"/>
+          </a:xfrm>
+          <a:prstGeom prst="rect">
+            <a:avLst/>
+          </a:prstGeom>
+          <a:noFill/>
+          <a:ln/>
+        </p:spPr>
+        <p:txBody>
+          <a:bodyPr wrap="none" lIns="0" tIns="0" rIns="0" bIns="0" rtlCol="0" anchor="ctr"/>
+          <a:lstStyle/>
+          <a:p>
             <a:pPr algn="ctr" indent="0" marL="0">
               <a:buNone/>
             </a:pPr>
             <a:r>
-              <a:rPr lang="en-US" sz="6500" b="1" dirty="0">
+              <a:rPr lang="en-US" sz="6000" b="1" dirty="0">
+                <a:solidFill>
+                  <a:srgbClr val="8DBBF2"/>
+                </a:solidFill>
+                <a:latin typeface="Poppins" pitchFamily="34" charset="0"/>
+                <a:ea typeface="Poppins" pitchFamily="34" charset="-122"/>
+                <a:cs typeface="Poppins" pitchFamily="34" charset="-120"/>
+              </a:rPr>
+              <a:t>c · </a:t>
+            </a:r>
+            <a:pPr algn="ctr" indent="0" marL="0">
+              <a:buNone/>
+            </a:pPr>
+            <a:r>
+              <a:rPr lang="en-US" sz="6000" b="1" dirty="0">
                 <a:solidFill>
                   <a:srgbClr val="8DBBF2"/>
                 </a:solidFill>
@@ -2032,7 +2085,7 @@
               <a:buNone/>
             </a:pPr>
             <a:r>
-              <a:rPr lang="en-US" sz="6500" b="1" baseline="-40000" dirty="0">
+              <a:rPr lang="en-US" sz="6000" b="1" baseline="-40000" dirty="0">
                 <a:solidFill>
                   <a:srgbClr val="8DBBF2"/>
                 </a:solidFill>
@@ -2042,11 +2095,36 @@
               </a:rPr>
               <a:t>c</a:t>
             </a:r>
+            <a:endParaRPr lang="en-US" sz="6000" dirty="0"/>
+          </a:p>
+        </p:txBody>
+      </p:sp>
+      <p:sp>
+        <p:nvSpPr>
+          <p:cNvPr id="6" name="Formel 10 Text 3"/>
+          <p:cNvSpPr txBox="1"/>
+          <p:nvPr/>
+        </p:nvSpPr>
+        <p:spPr>
+          <a:xfrm>
+            <a:off x="6591895" y="3429000"/>
+            <a:ext cx="629007" cy="1066800"/>
+          </a:xfrm>
+          <a:prstGeom prst="rect">
+            <a:avLst/>
+          </a:prstGeom>
+          <a:noFill/>
+          <a:ln/>
+        </p:spPr>
+        <p:txBody>
+          <a:bodyPr wrap="none" lIns="0" tIns="0" rIns="0" bIns="0" rtlCol="0" anchor="ctr"/>
+          <a:lstStyle/>
+          <a:p>
             <a:pPr algn="ctr" indent="0" marL="0">
               <a:buNone/>
             </a:pPr>
             <a:r>
-              <a:rPr lang="en-US" sz="6500" b="1" dirty="0">
+              <a:rPr lang="en-US" sz="6000" b="1" dirty="0">
                 <a:solidFill>
                   <a:srgbClr val="8DBBF2"/>
                 </a:solidFill>
@@ -2054,11 +2132,36 @@
                 <a:ea typeface="Poppins" pitchFamily="34" charset="-122"/>
                 <a:cs typeface="Poppins" pitchFamily="34" charset="-120"/>
               </a:rPr>
-              <a:t> : 2</a:t>
-            </a:r>
-            <a:endParaRPr lang="en-US" sz="6500" dirty="0"/>
-          </a:p>
-        </p:txBody>
+              <a:t>2</a:t>
+            </a:r>
+            <a:endParaRPr lang="en-US" sz="6000" dirty="0"/>
+          </a:p>
+        </p:txBody>
+      </p:sp>
+      <p:sp>
+        <p:nvSpPr>
+          <p:cNvPr id="7" name="Formel 10 Bruchstrich"/>
+          <p:cNvSpPr/>
+          <p:nvPr/>
+        </p:nvSpPr>
+        <p:spPr>
+          <a:xfrm>
+            <a:off x="5697498" y="3398520"/>
+            <a:ext cx="2417802" cy="60960"/>
+          </a:xfrm>
+          <a:prstGeom prst="rect">
+            <a:avLst/>
+          </a:prstGeom>
+          <a:solidFill>
+            <a:srgbClr val="8DBBF2"/>
+          </a:solidFill>
+          <a:ln w="12700">
+            <a:solidFill>
+              <a:srgbClr val="8DBBF2"/>
+            </a:solidFill>
+            <a:prstDash val="solid"/>
+          </a:ln>
+        </p:spPr>
       </p:sp>
     </p:spTree>
   </p:cSld>
@@ -2094,18 +2197,18 @@
       </p:grpSpPr>
       <p:sp>
         <p:nvSpPr>
-          <p:cNvPr id="3" name="Formel-Fläche"/>
+          <p:cNvPr id="3" name="Formel 11 Fläche Allgemeines Dreieck (Grundseite a)"/>
           <p:cNvSpPr/>
           <p:nvPr/>
         </p:nvSpPr>
         <p:spPr>
           <a:xfrm>
-            <a:off x="2914650" y="2552700"/>
-            <a:ext cx="6362700" cy="1752600"/>
+            <a:off x="3474720" y="2133600"/>
+            <a:ext cx="5242560" cy="2590800"/>
           </a:xfrm>
           <a:prstGeom prst="roundRect">
             <a:avLst>
-              <a:gd name="adj" fmla="val 15652"/>
+              <a:gd name="adj" fmla="val 12353"/>
             </a:avLst>
           </a:prstGeom>
           <a:solidFill>
@@ -2121,14 +2224,14 @@
       </p:sp>
       <p:sp>
         <p:nvSpPr>
-          <p:cNvPr id="4" name="Formel 11 Allgemeines Dreieck (Grundseite a)"/>
+          <p:cNvPr id="4" name="Formel 11 Text 1"/>
           <p:cNvSpPr txBox="1"/>
           <p:nvPr/>
         </p:nvSpPr>
         <p:spPr>
           <a:xfrm>
-            <a:off x="2914650" y="2552700"/>
-            <a:ext cx="6362700" cy="1752600"/>
+            <a:off x="4038600" y="2895600"/>
+            <a:ext cx="1712238" cy="1066800"/>
           </a:xfrm>
           <a:prstGeom prst="rect">
             <a:avLst/>
@@ -2137,14 +2240,14 @@
           <a:ln/>
         </p:spPr>
         <p:txBody>
-          <a:bodyPr wrap="square" lIns="0" tIns="0" rIns="0" bIns="0" rtlCol="0" anchor="ctr"/>
+          <a:bodyPr wrap="none" lIns="0" tIns="0" rIns="0" bIns="0" rtlCol="0" anchor="ctr"/>
           <a:lstStyle/>
           <a:p>
             <a:pPr algn="ctr" indent="0" marL="0">
               <a:buNone/>
             </a:pPr>
             <a:r>
-              <a:rPr lang="en-US" sz="6500" b="1" dirty="0">
+              <a:rPr lang="en-US" sz="6000" b="1" dirty="0">
                 <a:solidFill>
                   <a:srgbClr val="8DBBF2"/>
                 </a:solidFill>
@@ -2152,13 +2255,52 @@
                 <a:ea typeface="Poppins" pitchFamily="34" charset="-122"/>
                 <a:cs typeface="Poppins" pitchFamily="34" charset="-120"/>
               </a:rPr>
-              <a:t>A = a · </a:t>
-            </a:r>
+              <a:t>A = </a:t>
+            </a:r>
+            <a:endParaRPr lang="en-US" sz="6000" dirty="0"/>
+          </a:p>
+        </p:txBody>
+      </p:sp>
+      <p:sp>
+        <p:nvSpPr>
+          <p:cNvPr id="5" name="Formel 11 Text 2"/>
+          <p:cNvSpPr txBox="1"/>
+          <p:nvPr/>
+        </p:nvSpPr>
+        <p:spPr>
+          <a:xfrm>
+            <a:off x="5849898" y="2392680"/>
+            <a:ext cx="2117408" cy="1066800"/>
+          </a:xfrm>
+          <a:prstGeom prst="rect">
+            <a:avLst/>
+          </a:prstGeom>
+          <a:noFill/>
+          <a:ln/>
+        </p:spPr>
+        <p:txBody>
+          <a:bodyPr wrap="none" lIns="0" tIns="0" rIns="0" bIns="0" rtlCol="0" anchor="ctr"/>
+          <a:lstStyle/>
+          <a:p>
             <a:pPr algn="ctr" indent="0" marL="0">
               <a:buNone/>
             </a:pPr>
             <a:r>
-              <a:rPr lang="en-US" sz="6500" b="1" dirty="0">
+              <a:rPr lang="en-US" sz="6000" b="1" dirty="0">
+                <a:solidFill>
+                  <a:srgbClr val="8DBBF2"/>
+                </a:solidFill>
+                <a:latin typeface="Poppins" pitchFamily="34" charset="0"/>
+                <a:ea typeface="Poppins" pitchFamily="34" charset="-122"/>
+                <a:cs typeface="Poppins" pitchFamily="34" charset="-120"/>
+              </a:rPr>
+              <a:t>a · </a:t>
+            </a:r>
+            <a:pPr algn="ctr" indent="0" marL="0">
+              <a:buNone/>
+            </a:pPr>
+            <a:r>
+              <a:rPr lang="en-US" sz="6000" b="1" dirty="0">
                 <a:solidFill>
                   <a:srgbClr val="8DBBF2"/>
                 </a:solidFill>
@@ -2172,7 +2314,7 @@
               <a:buNone/>
             </a:pPr>
             <a:r>
-              <a:rPr lang="en-US" sz="6500" b="1" baseline="-40000" dirty="0">
+              <a:rPr lang="en-US" sz="6000" b="1" baseline="-40000" dirty="0">
                 <a:solidFill>
                   <a:srgbClr val="8DBBF2"/>
                 </a:solidFill>
@@ -2182,11 +2324,36 @@
               </a:rPr>
               <a:t>a</a:t>
             </a:r>
+            <a:endParaRPr lang="en-US" sz="6000" dirty="0"/>
+          </a:p>
+        </p:txBody>
+      </p:sp>
+      <p:sp>
+        <p:nvSpPr>
+          <p:cNvPr id="6" name="Formel 11 Text 3"/>
+          <p:cNvSpPr txBox="1"/>
+          <p:nvPr/>
+        </p:nvSpPr>
+        <p:spPr>
+          <a:xfrm>
+            <a:off x="6594098" y="3429000"/>
+            <a:ext cx="629007" cy="1066800"/>
+          </a:xfrm>
+          <a:prstGeom prst="rect">
+            <a:avLst/>
+          </a:prstGeom>
+          <a:noFill/>
+          <a:ln/>
+        </p:spPr>
+        <p:txBody>
+          <a:bodyPr wrap="none" lIns="0" tIns="0" rIns="0" bIns="0" rtlCol="0" anchor="ctr"/>
+          <a:lstStyle/>
+          <a:p>
             <a:pPr algn="ctr" indent="0" marL="0">
               <a:buNone/>
             </a:pPr>
             <a:r>
-              <a:rPr lang="en-US" sz="6500" b="1" dirty="0">
+              <a:rPr lang="en-US" sz="6000" b="1" dirty="0">
                 <a:solidFill>
                   <a:srgbClr val="8DBBF2"/>
                 </a:solidFill>
@@ -2194,11 +2361,36 @@
                 <a:ea typeface="Poppins" pitchFamily="34" charset="-122"/>
                 <a:cs typeface="Poppins" pitchFamily="34" charset="-120"/>
               </a:rPr>
-              <a:t> : 2</a:t>
-            </a:r>
-            <a:endParaRPr lang="en-US" sz="6500" dirty="0"/>
-          </a:p>
-        </p:txBody>
+              <a:t>2</a:t>
+            </a:r>
+            <a:endParaRPr lang="en-US" sz="6000" dirty="0"/>
+          </a:p>
+        </p:txBody>
+      </p:sp>
+      <p:sp>
+        <p:nvSpPr>
+          <p:cNvPr id="7" name="Formel 11 Bruchstrich"/>
+          <p:cNvSpPr/>
+          <p:nvPr/>
+        </p:nvSpPr>
+        <p:spPr>
+          <a:xfrm>
+            <a:off x="5705118" y="3398520"/>
+            <a:ext cx="2406968" cy="60960"/>
+          </a:xfrm>
+          <a:prstGeom prst="rect">
+            <a:avLst/>
+          </a:prstGeom>
+          <a:solidFill>
+            <a:srgbClr val="8DBBF2"/>
+          </a:solidFill>
+          <a:ln w="12700">
+            <a:solidFill>
+              <a:srgbClr val="8DBBF2"/>
+            </a:solidFill>
+            <a:prstDash val="solid"/>
+          </a:ln>
+        </p:spPr>
       </p:sp>
     </p:spTree>
   </p:cSld>
@@ -2234,18 +2426,18 @@
       </p:grpSpPr>
       <p:sp>
         <p:nvSpPr>
-          <p:cNvPr id="3" name="Formel-Fläche"/>
+          <p:cNvPr id="3" name="Formel 12 Fläche Allgemeines Dreieck (Grundseite b)"/>
           <p:cNvSpPr/>
           <p:nvPr/>
         </p:nvSpPr>
         <p:spPr>
           <a:xfrm>
-            <a:off x="2876550" y="2552700"/>
-            <a:ext cx="6438900" cy="1752600"/>
+            <a:off x="3440430" y="2133600"/>
+            <a:ext cx="5311140" cy="2590800"/>
           </a:xfrm>
           <a:prstGeom prst="roundRect">
             <a:avLst>
-              <a:gd name="adj" fmla="val 15652"/>
+              <a:gd name="adj" fmla="val 12353"/>
             </a:avLst>
           </a:prstGeom>
           <a:solidFill>
@@ -2261,14 +2453,14 @@
       </p:sp>
       <p:sp>
         <p:nvSpPr>
-          <p:cNvPr id="4" name="Formel 12 Allgemeines Dreieck (Grundseite b)"/>
+          <p:cNvPr id="4" name="Formel 12 Text 1"/>
           <p:cNvSpPr txBox="1"/>
           <p:nvPr/>
         </p:nvSpPr>
         <p:spPr>
           <a:xfrm>
-            <a:off x="2876550" y="2552700"/>
-            <a:ext cx="6438900" cy="1752600"/>
+            <a:off x="4004310" y="2895600"/>
+            <a:ext cx="1712238" cy="1066800"/>
           </a:xfrm>
           <a:prstGeom prst="rect">
             <a:avLst/>
@@ -2277,14 +2469,14 @@
           <a:ln/>
         </p:spPr>
         <p:txBody>
-          <a:bodyPr wrap="square" lIns="0" tIns="0" rIns="0" bIns="0" rtlCol="0" anchor="ctr"/>
+          <a:bodyPr wrap="none" lIns="0" tIns="0" rIns="0" bIns="0" rtlCol="0" anchor="ctr"/>
           <a:lstStyle/>
           <a:p>
             <a:pPr algn="ctr" indent="0" marL="0">
               <a:buNone/>
             </a:pPr>
             <a:r>
-              <a:rPr lang="en-US" sz="6500" b="1" dirty="0">
+              <a:rPr lang="en-US" sz="6000" b="1" dirty="0">
                 <a:solidFill>
                   <a:srgbClr val="8DBBF2"/>
                 </a:solidFill>
@@ -2292,13 +2484,52 @@
                 <a:ea typeface="Poppins" pitchFamily="34" charset="-122"/>
                 <a:cs typeface="Poppins" pitchFamily="34" charset="-120"/>
               </a:rPr>
-              <a:t>A = b · </a:t>
-            </a:r>
+              <a:t>A = </a:t>
+            </a:r>
+            <a:endParaRPr lang="en-US" sz="6000" dirty="0"/>
+          </a:p>
+        </p:txBody>
+      </p:sp>
+      <p:sp>
+        <p:nvSpPr>
+          <p:cNvPr id="5" name="Formel 12 Text 2"/>
+          <p:cNvSpPr txBox="1"/>
+          <p:nvPr/>
+        </p:nvSpPr>
+        <p:spPr>
+          <a:xfrm>
+            <a:off x="5815608" y="2392680"/>
+            <a:ext cx="2186464" cy="1066800"/>
+          </a:xfrm>
+          <a:prstGeom prst="rect">
+            <a:avLst/>
+          </a:prstGeom>
+          <a:noFill/>
+          <a:ln/>
+        </p:spPr>
+        <p:txBody>
+          <a:bodyPr wrap="none" lIns="0" tIns="0" rIns="0" bIns="0" rtlCol="0" anchor="ctr"/>
+          <a:lstStyle/>
+          <a:p>
             <a:pPr algn="ctr" indent="0" marL="0">
               <a:buNone/>
             </a:pPr>
             <a:r>
-              <a:rPr lang="en-US" sz="6500" b="1" dirty="0">
+              <a:rPr lang="en-US" sz="6000" b="1" dirty="0">
+                <a:solidFill>
+                  <a:srgbClr val="8DBBF2"/>
+                </a:solidFill>
+                <a:latin typeface="Poppins" pitchFamily="34" charset="0"/>
+                <a:ea typeface="Poppins" pitchFamily="34" charset="-122"/>
+                <a:cs typeface="Poppins" pitchFamily="34" charset="-120"/>
+              </a:rPr>
+              <a:t>b · </a:t>
+            </a:r>
+            <a:pPr algn="ctr" indent="0" marL="0">
+              <a:buNone/>
+            </a:pPr>
+            <a:r>
+              <a:rPr lang="en-US" sz="6000" b="1" dirty="0">
                 <a:solidFill>
                   <a:srgbClr val="8DBBF2"/>
                 </a:solidFill>
@@ -2312,7 +2543,7 @@
               <a:buNone/>
             </a:pPr>
             <a:r>
-              <a:rPr lang="en-US" sz="6500" b="1" baseline="-40000" dirty="0">
+              <a:rPr lang="en-US" sz="6000" b="1" baseline="-40000" dirty="0">
                 <a:solidFill>
                   <a:srgbClr val="8DBBF2"/>
                 </a:solidFill>
@@ -2322,11 +2553,36 @@
               </a:rPr>
               <a:t>b</a:t>
             </a:r>
+            <a:endParaRPr lang="en-US" sz="6000" dirty="0"/>
+          </a:p>
+        </p:txBody>
+      </p:sp>
+      <p:sp>
+        <p:nvSpPr>
+          <p:cNvPr id="6" name="Formel 12 Text 3"/>
+          <p:cNvSpPr txBox="1"/>
+          <p:nvPr/>
+        </p:nvSpPr>
+        <p:spPr>
+          <a:xfrm>
+            <a:off x="6594336" y="3429000"/>
+            <a:ext cx="629007" cy="1066800"/>
+          </a:xfrm>
+          <a:prstGeom prst="rect">
+            <a:avLst/>
+          </a:prstGeom>
+          <a:noFill/>
+          <a:ln/>
+        </p:spPr>
+        <p:txBody>
+          <a:bodyPr wrap="none" lIns="0" tIns="0" rIns="0" bIns="0" rtlCol="0" anchor="ctr"/>
+          <a:lstStyle/>
+          <a:p>
             <a:pPr algn="ctr" indent="0" marL="0">
               <a:buNone/>
             </a:pPr>
             <a:r>
-              <a:rPr lang="en-US" sz="6500" b="1" dirty="0">
+              <a:rPr lang="en-US" sz="6000" b="1" dirty="0">
                 <a:solidFill>
                   <a:srgbClr val="8DBBF2"/>
                 </a:solidFill>
@@ -2334,11 +2590,36 @@
                 <a:ea typeface="Poppins" pitchFamily="34" charset="-122"/>
                 <a:cs typeface="Poppins" pitchFamily="34" charset="-120"/>
               </a:rPr>
-              <a:t> : 2</a:t>
-            </a:r>
-            <a:endParaRPr lang="en-US" sz="6500" dirty="0"/>
-          </a:p>
-        </p:txBody>
+              <a:t>2</a:t>
+            </a:r>
+            <a:endParaRPr lang="en-US" sz="6000" dirty="0"/>
+          </a:p>
+        </p:txBody>
+      </p:sp>
+      <p:sp>
+        <p:nvSpPr>
+          <p:cNvPr id="7" name="Formel 12 Bruchstrich"/>
+          <p:cNvSpPr/>
+          <p:nvPr/>
+        </p:nvSpPr>
+        <p:spPr>
+          <a:xfrm>
+            <a:off x="5670828" y="3398520"/>
+            <a:ext cx="2476024" cy="60960"/>
+          </a:xfrm>
+          <a:prstGeom prst="rect">
+            <a:avLst/>
+          </a:prstGeom>
+          <a:solidFill>
+            <a:srgbClr val="8DBBF2"/>
+          </a:solidFill>
+          <a:ln w="12700">
+            <a:solidFill>
+              <a:srgbClr val="8DBBF2"/>
+            </a:solidFill>
+            <a:prstDash val="solid"/>
+          </a:ln>
+        </p:spPr>
       </p:sp>
     </p:spTree>
   </p:cSld>
@@ -2374,18 +2655,18 @@
       </p:grpSpPr>
       <p:sp>
         <p:nvSpPr>
-          <p:cNvPr id="3" name="Formel-Fläche"/>
+          <p:cNvPr id="3" name="Formel 02 Fläche Quadrat"/>
           <p:cNvSpPr/>
           <p:nvPr/>
         </p:nvSpPr>
         <p:spPr>
           <a:xfrm>
-            <a:off x="3756660" y="2552700"/>
-            <a:ext cx="4678680" cy="1752600"/>
+            <a:off x="3836670" y="2133600"/>
+            <a:ext cx="4518660" cy="2590800"/>
           </a:xfrm>
           <a:prstGeom prst="roundRect">
             <a:avLst>
-              <a:gd name="adj" fmla="val 15652"/>
+              <a:gd name="adj" fmla="val 12353"/>
             </a:avLst>
           </a:prstGeom>
           <a:solidFill>
@@ -2401,14 +2682,14 @@
       </p:sp>
       <p:sp>
         <p:nvSpPr>
-          <p:cNvPr id="4" name="Formel 02 Quadrat"/>
+          <p:cNvPr id="4" name="Formel 02 Text 1"/>
           <p:cNvSpPr txBox="1"/>
           <p:nvPr/>
         </p:nvSpPr>
         <p:spPr>
           <a:xfrm>
-            <a:off x="3756660" y="2552700"/>
-            <a:ext cx="4678680" cy="1752600"/>
+            <a:off x="4400550" y="2895600"/>
+            <a:ext cx="3392686" cy="1066800"/>
           </a:xfrm>
           <a:prstGeom prst="rect">
             <a:avLst/>
@@ -2417,14 +2698,14 @@
           <a:ln/>
         </p:spPr>
         <p:txBody>
-          <a:bodyPr wrap="square" lIns="0" tIns="0" rIns="0" bIns="0" rtlCol="0" anchor="ctr"/>
+          <a:bodyPr wrap="none" lIns="0" tIns="0" rIns="0" bIns="0" rtlCol="0" anchor="ctr"/>
           <a:lstStyle/>
           <a:p>
             <a:pPr algn="ctr" indent="0" marL="0">
               <a:buNone/>
             </a:pPr>
             <a:r>
-              <a:rPr lang="en-US" sz="6500" b="1" dirty="0">
+              <a:rPr lang="en-US" sz="6000" b="1" dirty="0">
                 <a:solidFill>
                   <a:srgbClr val="8DBBF2"/>
                 </a:solidFill>
@@ -2432,9 +2713,23 @@
                 <a:ea typeface="Poppins" pitchFamily="34" charset="-122"/>
                 <a:cs typeface="Poppins" pitchFamily="34" charset="-120"/>
               </a:rPr>
-              <a:t>A = a · a</a:t>
-            </a:r>
-            <a:endParaRPr lang="en-US" sz="6500" dirty="0"/>
+              <a:t>A = </a:t>
+            </a:r>
+            <a:pPr algn="ctr" indent="0" marL="0">
+              <a:buNone/>
+            </a:pPr>
+            <a:r>
+              <a:rPr lang="en-US" sz="6000" b="1" dirty="0">
+                <a:solidFill>
+                  <a:srgbClr val="8DBBF2"/>
+                </a:solidFill>
+                <a:latin typeface="Poppins" pitchFamily="34" charset="0"/>
+                <a:ea typeface="Poppins" pitchFamily="34" charset="-122"/>
+                <a:cs typeface="Poppins" pitchFamily="34" charset="-120"/>
+              </a:rPr>
+              <a:t>a · a</a:t>
+            </a:r>
+            <a:endParaRPr lang="en-US" sz="6000" dirty="0"/>
           </a:p>
         </p:txBody>
       </p:sp>
@@ -2472,18 +2767,18 @@
       </p:grpSpPr>
       <p:sp>
         <p:nvSpPr>
-          <p:cNvPr id="3" name="Formel-Fläche"/>
+          <p:cNvPr id="3" name="Formel 03 Fläche Rechtwinkliges Dreieck"/>
           <p:cNvSpPr/>
           <p:nvPr/>
         </p:nvSpPr>
         <p:spPr>
           <a:xfrm>
-            <a:off x="3078480" y="2552700"/>
-            <a:ext cx="6035040" cy="1752600"/>
+            <a:off x="3627120" y="2133600"/>
+            <a:ext cx="4937760" cy="2590800"/>
           </a:xfrm>
           <a:prstGeom prst="roundRect">
             <a:avLst>
-              <a:gd name="adj" fmla="val 15652"/>
+              <a:gd name="adj" fmla="val 12353"/>
             </a:avLst>
           </a:prstGeom>
           <a:solidFill>
@@ -2499,14 +2794,14 @@
       </p:sp>
       <p:sp>
         <p:nvSpPr>
-          <p:cNvPr id="4" name="Formel 03 Rechtwinkliges Dreieck"/>
+          <p:cNvPr id="4" name="Formel 03 Text 1"/>
           <p:cNvSpPr txBox="1"/>
           <p:nvPr/>
         </p:nvSpPr>
         <p:spPr>
           <a:xfrm>
-            <a:off x="3078480" y="2552700"/>
-            <a:ext cx="6035040" cy="1752600"/>
+            <a:off x="4191000" y="2895600"/>
+            <a:ext cx="1712238" cy="1066800"/>
           </a:xfrm>
           <a:prstGeom prst="rect">
             <a:avLst/>
@@ -2515,14 +2810,14 @@
           <a:ln/>
         </p:spPr>
         <p:txBody>
-          <a:bodyPr wrap="square" lIns="0" tIns="0" rIns="0" bIns="0" rtlCol="0" anchor="ctr"/>
+          <a:bodyPr wrap="none" lIns="0" tIns="0" rIns="0" bIns="0" rtlCol="0" anchor="ctr"/>
           <a:lstStyle/>
           <a:p>
             <a:pPr algn="ctr" indent="0" marL="0">
               <a:buNone/>
             </a:pPr>
             <a:r>
-              <a:rPr lang="en-US" sz="6500" b="1" dirty="0">
+              <a:rPr lang="en-US" sz="6000" b="1" dirty="0">
                 <a:solidFill>
                   <a:srgbClr val="8DBBF2"/>
                 </a:solidFill>
@@ -2530,11 +2825,114 @@
                 <a:ea typeface="Poppins" pitchFamily="34" charset="-122"/>
                 <a:cs typeface="Poppins" pitchFamily="34" charset="-120"/>
               </a:rPr>
-              <a:t>A = a · b : 2</a:t>
-            </a:r>
-            <a:endParaRPr lang="en-US" sz="6500" dirty="0"/>
-          </a:p>
-        </p:txBody>
+              <a:t>A = </a:t>
+            </a:r>
+            <a:endParaRPr lang="en-US" sz="6000" dirty="0"/>
+          </a:p>
+        </p:txBody>
+      </p:sp>
+      <p:sp>
+        <p:nvSpPr>
+          <p:cNvPr id="5" name="Formel 03 Text 2"/>
+          <p:cNvSpPr txBox="1"/>
+          <p:nvPr/>
+        </p:nvSpPr>
+        <p:spPr>
+          <a:xfrm>
+            <a:off x="6002298" y="2392680"/>
+            <a:ext cx="1814393" cy="1066800"/>
+          </a:xfrm>
+          <a:prstGeom prst="rect">
+            <a:avLst/>
+          </a:prstGeom>
+          <a:noFill/>
+          <a:ln/>
+        </p:spPr>
+        <p:txBody>
+          <a:bodyPr wrap="none" lIns="0" tIns="0" rIns="0" bIns="0" rtlCol="0" anchor="ctr"/>
+          <a:lstStyle/>
+          <a:p>
+            <a:pPr algn="ctr" indent="0" marL="0">
+              <a:buNone/>
+            </a:pPr>
+            <a:r>
+              <a:rPr lang="en-US" sz="6000" b="1" dirty="0">
+                <a:solidFill>
+                  <a:srgbClr val="8DBBF2"/>
+                </a:solidFill>
+                <a:latin typeface="Poppins" pitchFamily="34" charset="0"/>
+                <a:ea typeface="Poppins" pitchFamily="34" charset="-122"/>
+                <a:cs typeface="Poppins" pitchFamily="34" charset="-120"/>
+              </a:rPr>
+              <a:t>a · b</a:t>
+            </a:r>
+            <a:endParaRPr lang="en-US" sz="6000" dirty="0"/>
+          </a:p>
+        </p:txBody>
+      </p:sp>
+      <p:sp>
+        <p:nvSpPr>
+          <p:cNvPr id="6" name="Formel 03 Text 3"/>
+          <p:cNvSpPr txBox="1"/>
+          <p:nvPr/>
+        </p:nvSpPr>
+        <p:spPr>
+          <a:xfrm>
+            <a:off x="6594991" y="3429000"/>
+            <a:ext cx="629007" cy="1066800"/>
+          </a:xfrm>
+          <a:prstGeom prst="rect">
+            <a:avLst/>
+          </a:prstGeom>
+          <a:noFill/>
+          <a:ln/>
+        </p:spPr>
+        <p:txBody>
+          <a:bodyPr wrap="none" lIns="0" tIns="0" rIns="0" bIns="0" rtlCol="0" anchor="ctr"/>
+          <a:lstStyle/>
+          <a:p>
+            <a:pPr algn="ctr" indent="0" marL="0">
+              <a:buNone/>
+            </a:pPr>
+            <a:r>
+              <a:rPr lang="en-US" sz="6000" b="1" dirty="0">
+                <a:solidFill>
+                  <a:srgbClr val="8DBBF2"/>
+                </a:solidFill>
+                <a:latin typeface="Poppins" pitchFamily="34" charset="0"/>
+                <a:ea typeface="Poppins" pitchFamily="34" charset="-122"/>
+                <a:cs typeface="Poppins" pitchFamily="34" charset="-120"/>
+              </a:rPr>
+              <a:t>2</a:t>
+            </a:r>
+            <a:endParaRPr lang="en-US" sz="6000" dirty="0"/>
+          </a:p>
+        </p:txBody>
+      </p:sp>
+      <p:sp>
+        <p:nvSpPr>
+          <p:cNvPr id="7" name="Formel 03 Bruchstrich"/>
+          <p:cNvSpPr/>
+          <p:nvPr/>
+        </p:nvSpPr>
+        <p:spPr>
+          <a:xfrm>
+            <a:off x="5857518" y="3398520"/>
+            <a:ext cx="2103953" cy="60960"/>
+          </a:xfrm>
+          <a:prstGeom prst="rect">
+            <a:avLst/>
+          </a:prstGeom>
+          <a:solidFill>
+            <a:srgbClr val="8DBBF2"/>
+          </a:solidFill>
+          <a:ln w="12700">
+            <a:solidFill>
+              <a:srgbClr val="8DBBF2"/>
+            </a:solidFill>
+            <a:prstDash val="solid"/>
+          </a:ln>
+        </p:spPr>
       </p:sp>
     </p:spTree>
   </p:cSld>
@@ -2570,18 +2968,18 @@
       </p:grpSpPr>
       <p:sp>
         <p:nvSpPr>
-          <p:cNvPr id="3" name="Formel-Fläche"/>
+          <p:cNvPr id="3" name="Formel 04 Fläche Parallelogramm (Grundseite a)"/>
           <p:cNvSpPr/>
           <p:nvPr/>
         </p:nvSpPr>
         <p:spPr>
           <a:xfrm>
-            <a:off x="3569970" y="2552700"/>
-            <a:ext cx="5052060" cy="1752600"/>
+            <a:off x="3665220" y="2133600"/>
+            <a:ext cx="4861560" cy="2590800"/>
           </a:xfrm>
           <a:prstGeom prst="roundRect">
             <a:avLst>
-              <a:gd name="adj" fmla="val 15652"/>
+              <a:gd name="adj" fmla="val 12353"/>
             </a:avLst>
           </a:prstGeom>
           <a:solidFill>
@@ -2597,14 +2995,14 @@
       </p:sp>
       <p:sp>
         <p:nvSpPr>
-          <p:cNvPr id="4" name="Formel 04 Parallelogramm (Grundseite a)"/>
+          <p:cNvPr id="4" name="Formel 04 Text 1"/>
           <p:cNvSpPr txBox="1"/>
           <p:nvPr/>
         </p:nvSpPr>
         <p:spPr>
           <a:xfrm>
-            <a:off x="3569970" y="2552700"/>
-            <a:ext cx="5052060" cy="1752600"/>
+            <a:off x="4229100" y="2895600"/>
+            <a:ext cx="3738205" cy="1066800"/>
           </a:xfrm>
           <a:prstGeom prst="rect">
             <a:avLst/>
@@ -2613,14 +3011,14 @@
           <a:ln/>
         </p:spPr>
         <p:txBody>
-          <a:bodyPr wrap="square" lIns="0" tIns="0" rIns="0" bIns="0" rtlCol="0" anchor="ctr"/>
+          <a:bodyPr wrap="none" lIns="0" tIns="0" rIns="0" bIns="0" rtlCol="0" anchor="ctr"/>
           <a:lstStyle/>
           <a:p>
             <a:pPr algn="ctr" indent="0" marL="0">
               <a:buNone/>
             </a:pPr>
             <a:r>
-              <a:rPr lang="en-US" sz="6500" b="1" dirty="0">
+              <a:rPr lang="en-US" sz="6000" b="1" dirty="0">
                 <a:solidFill>
                   <a:srgbClr val="8DBBF2"/>
                 </a:solidFill>
@@ -2628,13 +3026,27 @@
                 <a:ea typeface="Poppins" pitchFamily="34" charset="-122"/>
                 <a:cs typeface="Poppins" pitchFamily="34" charset="-120"/>
               </a:rPr>
-              <a:t>A = a · </a:t>
+              <a:t>A = </a:t>
             </a:r>
             <a:pPr algn="ctr" indent="0" marL="0">
               <a:buNone/>
             </a:pPr>
             <a:r>
-              <a:rPr lang="en-US" sz="6500" b="1" dirty="0">
+              <a:rPr lang="en-US" sz="6000" b="1" dirty="0">
+                <a:solidFill>
+                  <a:srgbClr val="8DBBF2"/>
+                </a:solidFill>
+                <a:latin typeface="Poppins" pitchFamily="34" charset="0"/>
+                <a:ea typeface="Poppins" pitchFamily="34" charset="-122"/>
+                <a:cs typeface="Poppins" pitchFamily="34" charset="-120"/>
+              </a:rPr>
+              <a:t>a · </a:t>
+            </a:r>
+            <a:pPr algn="ctr" indent="0" marL="0">
+              <a:buNone/>
+            </a:pPr>
+            <a:r>
+              <a:rPr lang="en-US" sz="6000" b="1" dirty="0">
                 <a:solidFill>
                   <a:srgbClr val="8DBBF2"/>
                 </a:solidFill>
@@ -2648,7 +3060,7 @@
               <a:buNone/>
             </a:pPr>
             <a:r>
-              <a:rPr lang="en-US" sz="6500" b="1" baseline="-40000" dirty="0">
+              <a:rPr lang="en-US" sz="6000" b="1" baseline="-40000" dirty="0">
                 <a:solidFill>
                   <a:srgbClr val="8DBBF2"/>
                 </a:solidFill>
@@ -2658,7 +3070,7 @@
               </a:rPr>
               <a:t>a</a:t>
             </a:r>
-            <a:endParaRPr lang="en-US" sz="6500" dirty="0"/>
+            <a:endParaRPr lang="en-US" sz="6000" dirty="0"/>
           </a:p>
         </p:txBody>
       </p:sp>
@@ -2696,18 +3108,18 @@
       </p:grpSpPr>
       <p:sp>
         <p:nvSpPr>
-          <p:cNvPr id="3" name="Formel-Fläche"/>
+          <p:cNvPr id="3" name="Formel 05 Fläche Parallelogramm (Grundseite b)"/>
           <p:cNvSpPr/>
           <p:nvPr/>
         </p:nvSpPr>
         <p:spPr>
           <a:xfrm>
-            <a:off x="3531870" y="2552700"/>
-            <a:ext cx="5128260" cy="1752600"/>
+            <a:off x="3630930" y="2133600"/>
+            <a:ext cx="4930140" cy="2590800"/>
           </a:xfrm>
           <a:prstGeom prst="roundRect">
             <a:avLst>
-              <a:gd name="adj" fmla="val 15652"/>
+              <a:gd name="adj" fmla="val 12353"/>
             </a:avLst>
           </a:prstGeom>
           <a:solidFill>
@@ -2723,14 +3135,14 @@
       </p:sp>
       <p:sp>
         <p:nvSpPr>
-          <p:cNvPr id="4" name="Formel 05 Parallelogramm (Grundseite b)"/>
+          <p:cNvPr id="4" name="Formel 05 Text 1"/>
           <p:cNvSpPr txBox="1"/>
           <p:nvPr/>
         </p:nvSpPr>
         <p:spPr>
           <a:xfrm>
-            <a:off x="3531870" y="2552700"/>
-            <a:ext cx="5128260" cy="1752600"/>
+            <a:off x="4194810" y="2895600"/>
+            <a:ext cx="3807262" cy="1066800"/>
           </a:xfrm>
           <a:prstGeom prst="rect">
             <a:avLst/>
@@ -2739,14 +3151,14 @@
           <a:ln/>
         </p:spPr>
         <p:txBody>
-          <a:bodyPr wrap="square" lIns="0" tIns="0" rIns="0" bIns="0" rtlCol="0" anchor="ctr"/>
+          <a:bodyPr wrap="none" lIns="0" tIns="0" rIns="0" bIns="0" rtlCol="0" anchor="ctr"/>
           <a:lstStyle/>
           <a:p>
             <a:pPr algn="ctr" indent="0" marL="0">
               <a:buNone/>
             </a:pPr>
             <a:r>
-              <a:rPr lang="en-US" sz="6500" b="1" dirty="0">
+              <a:rPr lang="en-US" sz="6000" b="1" dirty="0">
                 <a:solidFill>
                   <a:srgbClr val="8DBBF2"/>
                 </a:solidFill>
@@ -2754,13 +3166,27 @@
                 <a:ea typeface="Poppins" pitchFamily="34" charset="-122"/>
                 <a:cs typeface="Poppins" pitchFamily="34" charset="-120"/>
               </a:rPr>
-              <a:t>A = b · </a:t>
+              <a:t>A = </a:t>
             </a:r>
             <a:pPr algn="ctr" indent="0" marL="0">
               <a:buNone/>
             </a:pPr>
             <a:r>
-              <a:rPr lang="en-US" sz="6500" b="1" dirty="0">
+              <a:rPr lang="en-US" sz="6000" b="1" dirty="0">
+                <a:solidFill>
+                  <a:srgbClr val="8DBBF2"/>
+                </a:solidFill>
+                <a:latin typeface="Poppins" pitchFamily="34" charset="0"/>
+                <a:ea typeface="Poppins" pitchFamily="34" charset="-122"/>
+                <a:cs typeface="Poppins" pitchFamily="34" charset="-120"/>
+              </a:rPr>
+              <a:t>b · </a:t>
+            </a:r>
+            <a:pPr algn="ctr" indent="0" marL="0">
+              <a:buNone/>
+            </a:pPr>
+            <a:r>
+              <a:rPr lang="en-US" sz="6000" b="1" dirty="0">
                 <a:solidFill>
                   <a:srgbClr val="8DBBF2"/>
                 </a:solidFill>
@@ -2774,7 +3200,7 @@
               <a:buNone/>
             </a:pPr>
             <a:r>
-              <a:rPr lang="en-US" sz="6500" b="1" baseline="-40000" dirty="0">
+              <a:rPr lang="en-US" sz="6000" b="1" baseline="-40000" dirty="0">
                 <a:solidFill>
                   <a:srgbClr val="8DBBF2"/>
                 </a:solidFill>
@@ -2784,7 +3210,7 @@
               </a:rPr>
               <a:t>b</a:t>
             </a:r>
-            <a:endParaRPr lang="en-US" sz="6500" dirty="0"/>
+            <a:endParaRPr lang="en-US" sz="6000" dirty="0"/>
           </a:p>
         </p:txBody>
       </p:sp>
@@ -2822,18 +3248,18 @@
       </p:grpSpPr>
       <p:sp>
         <p:nvSpPr>
-          <p:cNvPr id="3" name="Formel-Fläche"/>
+          <p:cNvPr id="3" name="Formel 06 Fläche Raute (Seite a, Höhe h)"/>
           <p:cNvSpPr/>
           <p:nvPr/>
         </p:nvSpPr>
         <p:spPr>
           <a:xfrm>
-            <a:off x="3737610" y="2552700"/>
-            <a:ext cx="4716780" cy="1752600"/>
+            <a:off x="3821430" y="2133600"/>
+            <a:ext cx="4549140" cy="2590800"/>
           </a:xfrm>
           <a:prstGeom prst="roundRect">
             <a:avLst>
-              <a:gd name="adj" fmla="val 15652"/>
+              <a:gd name="adj" fmla="val 12353"/>
             </a:avLst>
           </a:prstGeom>
           <a:solidFill>
@@ -2849,14 +3275,14 @@
       </p:sp>
       <p:sp>
         <p:nvSpPr>
-          <p:cNvPr id="4" name="Formel 06 Raute (Seite a, Höhe h)"/>
+          <p:cNvPr id="4" name="Formel 06 Text 1"/>
           <p:cNvSpPr txBox="1"/>
           <p:nvPr/>
         </p:nvSpPr>
         <p:spPr>
           <a:xfrm>
-            <a:off x="3737610" y="2552700"/>
-            <a:ext cx="4716780" cy="1752600"/>
+            <a:off x="4385310" y="2895600"/>
+            <a:ext cx="3428524" cy="1066800"/>
           </a:xfrm>
           <a:prstGeom prst="rect">
             <a:avLst/>
@@ -2865,14 +3291,14 @@
           <a:ln/>
         </p:spPr>
         <p:txBody>
-          <a:bodyPr wrap="square" lIns="0" tIns="0" rIns="0" bIns="0" rtlCol="0" anchor="ctr"/>
+          <a:bodyPr wrap="none" lIns="0" tIns="0" rIns="0" bIns="0" rtlCol="0" anchor="ctr"/>
           <a:lstStyle/>
           <a:p>
             <a:pPr algn="ctr" indent="0" marL="0">
               <a:buNone/>
             </a:pPr>
             <a:r>
-              <a:rPr lang="en-US" sz="6500" b="1" dirty="0">
+              <a:rPr lang="en-US" sz="6000" b="1" dirty="0">
                 <a:solidFill>
                   <a:srgbClr val="8DBBF2"/>
                 </a:solidFill>
@@ -2880,9 +3306,23 @@
                 <a:ea typeface="Poppins" pitchFamily="34" charset="-122"/>
                 <a:cs typeface="Poppins" pitchFamily="34" charset="-120"/>
               </a:rPr>
-              <a:t>A = a · h</a:t>
-            </a:r>
-            <a:endParaRPr lang="en-US" sz="6500" dirty="0"/>
+              <a:t>A = </a:t>
+            </a:r>
+            <a:pPr algn="ctr" indent="0" marL="0">
+              <a:buNone/>
+            </a:pPr>
+            <a:r>
+              <a:rPr lang="en-US" sz="6000" b="1" dirty="0">
+                <a:solidFill>
+                  <a:srgbClr val="8DBBF2"/>
+                </a:solidFill>
+                <a:latin typeface="Poppins" pitchFamily="34" charset="0"/>
+                <a:ea typeface="Poppins" pitchFamily="34" charset="-122"/>
+                <a:cs typeface="Poppins" pitchFamily="34" charset="-120"/>
+              </a:rPr>
+              <a:t>a · h</a:t>
+            </a:r>
+            <a:endParaRPr lang="en-US" sz="6000" dirty="0"/>
           </a:p>
         </p:txBody>
       </p:sp>
@@ -2920,18 +3360,18 @@
       </p:grpSpPr>
       <p:sp>
         <p:nvSpPr>
-          <p:cNvPr id="3" name="Formel-Fläche"/>
+          <p:cNvPr id="3" name="Formel 07 Fläche Raute (Diagonalen e, f)"/>
           <p:cNvSpPr/>
           <p:nvPr/>
         </p:nvSpPr>
         <p:spPr>
           <a:xfrm>
-            <a:off x="3177540" y="2552700"/>
-            <a:ext cx="5836920" cy="1752600"/>
+            <a:off x="3718560" y="2133600"/>
+            <a:ext cx="4754880" cy="2590800"/>
           </a:xfrm>
           <a:prstGeom prst="roundRect">
             <a:avLst>
-              <a:gd name="adj" fmla="val 15652"/>
+              <a:gd name="adj" fmla="val 12353"/>
             </a:avLst>
           </a:prstGeom>
           <a:solidFill>
@@ -2947,14 +3387,14 @@
       </p:sp>
       <p:sp>
         <p:nvSpPr>
-          <p:cNvPr id="4" name="Formel 07 Raute (Diagonalen e, f)"/>
+          <p:cNvPr id="4" name="Formel 07 Text 1"/>
           <p:cNvSpPr txBox="1"/>
           <p:nvPr/>
         </p:nvSpPr>
         <p:spPr>
           <a:xfrm>
-            <a:off x="3177540" y="2552700"/>
-            <a:ext cx="5836920" cy="1752600"/>
+            <a:off x="4282440" y="2895600"/>
+            <a:ext cx="1712238" cy="1066800"/>
           </a:xfrm>
           <a:prstGeom prst="rect">
             <a:avLst/>
@@ -2963,14 +3403,14 @@
           <a:ln/>
         </p:spPr>
         <p:txBody>
-          <a:bodyPr wrap="square" lIns="0" tIns="0" rIns="0" bIns="0" rtlCol="0" anchor="ctr"/>
+          <a:bodyPr wrap="none" lIns="0" tIns="0" rIns="0" bIns="0" rtlCol="0" anchor="ctr"/>
           <a:lstStyle/>
           <a:p>
             <a:pPr algn="ctr" indent="0" marL="0">
               <a:buNone/>
             </a:pPr>
             <a:r>
-              <a:rPr lang="en-US" sz="6500" b="1" dirty="0">
+              <a:rPr lang="en-US" sz="6000" b="1" dirty="0">
                 <a:solidFill>
                   <a:srgbClr val="8DBBF2"/>
                 </a:solidFill>
@@ -2978,11 +3418,114 @@
                 <a:ea typeface="Poppins" pitchFamily="34" charset="-122"/>
                 <a:cs typeface="Poppins" pitchFamily="34" charset="-120"/>
               </a:rPr>
-              <a:t>A = e · f : 2</a:t>
-            </a:r>
-            <a:endParaRPr lang="en-US" sz="6500" dirty="0"/>
-          </a:p>
-        </p:txBody>
+              <a:t>A = </a:t>
+            </a:r>
+            <a:endParaRPr lang="en-US" sz="6000" dirty="0"/>
+          </a:p>
+        </p:txBody>
+      </p:sp>
+      <p:sp>
+        <p:nvSpPr>
+          <p:cNvPr id="5" name="Formel 07 Text 2"/>
+          <p:cNvSpPr txBox="1"/>
+          <p:nvPr/>
+        </p:nvSpPr>
+        <p:spPr>
+          <a:xfrm>
+            <a:off x="6093738" y="2392680"/>
+            <a:ext cx="1628894" cy="1066800"/>
+          </a:xfrm>
+          <a:prstGeom prst="rect">
+            <a:avLst/>
+          </a:prstGeom>
+          <a:noFill/>
+          <a:ln/>
+        </p:spPr>
+        <p:txBody>
+          <a:bodyPr wrap="none" lIns="0" tIns="0" rIns="0" bIns="0" rtlCol="0" anchor="ctr"/>
+          <a:lstStyle/>
+          <a:p>
+            <a:pPr algn="ctr" indent="0" marL="0">
+              <a:buNone/>
+            </a:pPr>
+            <a:r>
+              <a:rPr lang="en-US" sz="6000" b="1" dirty="0">
+                <a:solidFill>
+                  <a:srgbClr val="8DBBF2"/>
+                </a:solidFill>
+                <a:latin typeface="Poppins" pitchFamily="34" charset="0"/>
+                <a:ea typeface="Poppins" pitchFamily="34" charset="-122"/>
+                <a:cs typeface="Poppins" pitchFamily="34" charset="-120"/>
+              </a:rPr>
+              <a:t>e · f</a:t>
+            </a:r>
+            <a:endParaRPr lang="en-US" sz="6000" dirty="0"/>
+          </a:p>
+        </p:txBody>
+      </p:sp>
+      <p:sp>
+        <p:nvSpPr>
+          <p:cNvPr id="6" name="Formel 07 Text 3"/>
+          <p:cNvSpPr txBox="1"/>
+          <p:nvPr/>
+        </p:nvSpPr>
+        <p:spPr>
+          <a:xfrm>
+            <a:off x="6593681" y="3429000"/>
+            <a:ext cx="629007" cy="1066800"/>
+          </a:xfrm>
+          <a:prstGeom prst="rect">
+            <a:avLst/>
+          </a:prstGeom>
+          <a:noFill/>
+          <a:ln/>
+        </p:spPr>
+        <p:txBody>
+          <a:bodyPr wrap="none" lIns="0" tIns="0" rIns="0" bIns="0" rtlCol="0" anchor="ctr"/>
+          <a:lstStyle/>
+          <a:p>
+            <a:pPr algn="ctr" indent="0" marL="0">
+              <a:buNone/>
+            </a:pPr>
+            <a:r>
+              <a:rPr lang="en-US" sz="6000" b="1" dirty="0">
+                <a:solidFill>
+                  <a:srgbClr val="8DBBF2"/>
+                </a:solidFill>
+                <a:latin typeface="Poppins" pitchFamily="34" charset="0"/>
+                <a:ea typeface="Poppins" pitchFamily="34" charset="-122"/>
+                <a:cs typeface="Poppins" pitchFamily="34" charset="-120"/>
+              </a:rPr>
+              <a:t>2</a:t>
+            </a:r>
+            <a:endParaRPr lang="en-US" sz="6000" dirty="0"/>
+          </a:p>
+        </p:txBody>
+      </p:sp>
+      <p:sp>
+        <p:nvSpPr>
+          <p:cNvPr id="7" name="Formel 07 Bruchstrich"/>
+          <p:cNvSpPr/>
+          <p:nvPr/>
+        </p:nvSpPr>
+        <p:spPr>
+          <a:xfrm>
+            <a:off x="5948958" y="3398520"/>
+            <a:ext cx="1918454" cy="60960"/>
+          </a:xfrm>
+          <a:prstGeom prst="rect">
+            <a:avLst/>
+          </a:prstGeom>
+          <a:solidFill>
+            <a:srgbClr val="8DBBF2"/>
+          </a:solidFill>
+          <a:ln w="12700">
+            <a:solidFill>
+              <a:srgbClr val="8DBBF2"/>
+            </a:solidFill>
+            <a:prstDash val="solid"/>
+          </a:ln>
+        </p:spPr>
       </p:sp>
     </p:spTree>
   </p:cSld>
@@ -3018,18 +3561,18 @@
       </p:grpSpPr>
       <p:sp>
         <p:nvSpPr>
-          <p:cNvPr id="3" name="Formel-Fläche"/>
+          <p:cNvPr id="3" name="Formel 08 Fläche Trapez"/>
           <p:cNvSpPr/>
           <p:nvPr/>
         </p:nvSpPr>
         <p:spPr>
           <a:xfrm>
-            <a:off x="1946910" y="2552700"/>
-            <a:ext cx="8298180" cy="1752600"/>
+            <a:off x="2571750" y="2133600"/>
+            <a:ext cx="7048500" cy="2590800"/>
           </a:xfrm>
           <a:prstGeom prst="roundRect">
             <a:avLst>
-              <a:gd name="adj" fmla="val 15652"/>
+              <a:gd name="adj" fmla="val 12353"/>
             </a:avLst>
           </a:prstGeom>
           <a:solidFill>
@@ -3045,14 +3588,14 @@
       </p:sp>
       <p:sp>
         <p:nvSpPr>
-          <p:cNvPr id="4" name="Formel 08 Trapez"/>
+          <p:cNvPr id="4" name="Formel 08 Text 1"/>
           <p:cNvSpPr txBox="1"/>
           <p:nvPr/>
         </p:nvSpPr>
         <p:spPr>
           <a:xfrm>
-            <a:off x="1946910" y="2552700"/>
-            <a:ext cx="8298180" cy="1752600"/>
+            <a:off x="3135630" y="2895600"/>
+            <a:ext cx="1712238" cy="1066800"/>
           </a:xfrm>
           <a:prstGeom prst="rect">
             <a:avLst/>
@@ -3061,14 +3604,14 @@
           <a:ln/>
         </p:spPr>
         <p:txBody>
-          <a:bodyPr wrap="square" lIns="0" tIns="0" rIns="0" bIns="0" rtlCol="0" anchor="ctr"/>
+          <a:bodyPr wrap="none" lIns="0" tIns="0" rIns="0" bIns="0" rtlCol="0" anchor="ctr"/>
           <a:lstStyle/>
           <a:p>
             <a:pPr algn="ctr" indent="0" marL="0">
               <a:buNone/>
             </a:pPr>
             <a:r>
-              <a:rPr lang="en-US" sz="6500" b="1" dirty="0">
+              <a:rPr lang="en-US" sz="6000" b="1" dirty="0">
                 <a:solidFill>
                   <a:srgbClr val="8DBBF2"/>
                 </a:solidFill>
@@ -3076,11 +3619,114 @@
                 <a:ea typeface="Poppins" pitchFamily="34" charset="-122"/>
                 <a:cs typeface="Poppins" pitchFamily="34" charset="-120"/>
               </a:rPr>
-              <a:t>A = (a + c) · h : 2</a:t>
-            </a:r>
-            <a:endParaRPr lang="en-US" sz="6500" dirty="0"/>
-          </a:p>
-        </p:txBody>
+              <a:t>A = </a:t>
+            </a:r>
+            <a:endParaRPr lang="en-US" sz="6000" dirty="0"/>
+          </a:p>
+        </p:txBody>
+      </p:sp>
+      <p:sp>
+        <p:nvSpPr>
+          <p:cNvPr id="5" name="Formel 08 Text 2"/>
+          <p:cNvSpPr txBox="1"/>
+          <p:nvPr/>
+        </p:nvSpPr>
+        <p:spPr>
+          <a:xfrm>
+            <a:off x="4946928" y="2392680"/>
+            <a:ext cx="3926086" cy="1066800"/>
+          </a:xfrm>
+          <a:prstGeom prst="rect">
+            <a:avLst/>
+          </a:prstGeom>
+          <a:noFill/>
+          <a:ln/>
+        </p:spPr>
+        <p:txBody>
+          <a:bodyPr wrap="none" lIns="0" tIns="0" rIns="0" bIns="0" rtlCol="0" anchor="ctr"/>
+          <a:lstStyle/>
+          <a:p>
+            <a:pPr algn="ctr" indent="0" marL="0">
+              <a:buNone/>
+            </a:pPr>
+            <a:r>
+              <a:rPr lang="en-US" sz="6000" b="1" dirty="0">
+                <a:solidFill>
+                  <a:srgbClr val="8DBBF2"/>
+                </a:solidFill>
+                <a:latin typeface="Poppins" pitchFamily="34" charset="0"/>
+                <a:ea typeface="Poppins" pitchFamily="34" charset="-122"/>
+                <a:cs typeface="Poppins" pitchFamily="34" charset="-120"/>
+              </a:rPr>
+              <a:t>(a + c) · h</a:t>
+            </a:r>
+            <a:endParaRPr lang="en-US" sz="6000" dirty="0"/>
+          </a:p>
+        </p:txBody>
+      </p:sp>
+      <p:sp>
+        <p:nvSpPr>
+          <p:cNvPr id="6" name="Formel 08 Text 3"/>
+          <p:cNvSpPr txBox="1"/>
+          <p:nvPr/>
+        </p:nvSpPr>
+        <p:spPr>
+          <a:xfrm>
+            <a:off x="6595467" y="3429000"/>
+            <a:ext cx="629007" cy="1066800"/>
+          </a:xfrm>
+          <a:prstGeom prst="rect">
+            <a:avLst/>
+          </a:prstGeom>
+          <a:noFill/>
+          <a:ln/>
+        </p:spPr>
+        <p:txBody>
+          <a:bodyPr wrap="none" lIns="0" tIns="0" rIns="0" bIns="0" rtlCol="0" anchor="ctr"/>
+          <a:lstStyle/>
+          <a:p>
+            <a:pPr algn="ctr" indent="0" marL="0">
+              <a:buNone/>
+            </a:pPr>
+            <a:r>
+              <a:rPr lang="en-US" sz="6000" b="1" dirty="0">
+                <a:solidFill>
+                  <a:srgbClr val="8DBBF2"/>
+                </a:solidFill>
+                <a:latin typeface="Poppins" pitchFamily="34" charset="0"/>
+                <a:ea typeface="Poppins" pitchFamily="34" charset="-122"/>
+                <a:cs typeface="Poppins" pitchFamily="34" charset="-120"/>
+              </a:rPr>
+              <a:t>2</a:t>
+            </a:r>
+            <a:endParaRPr lang="en-US" sz="6000" dirty="0"/>
+          </a:p>
+        </p:txBody>
+      </p:sp>
+      <p:sp>
+        <p:nvSpPr>
+          <p:cNvPr id="7" name="Formel 08 Bruchstrich"/>
+          <p:cNvSpPr/>
+          <p:nvPr/>
+        </p:nvSpPr>
+        <p:spPr>
+          <a:xfrm>
+            <a:off x="4802148" y="3398520"/>
+            <a:ext cx="4215646" cy="60960"/>
+          </a:xfrm>
+          <a:prstGeom prst="rect">
+            <a:avLst/>
+          </a:prstGeom>
+          <a:solidFill>
+            <a:srgbClr val="8DBBF2"/>
+          </a:solidFill>
+          <a:ln w="12700">
+            <a:solidFill>
+              <a:srgbClr val="8DBBF2"/>
+            </a:solidFill>
+            <a:prstDash val="solid"/>
+          </a:ln>
+        </p:spPr>
       </p:sp>
     </p:spTree>
   </p:cSld>
@@ -3116,18 +3762,18 @@
       </p:grpSpPr>
       <p:sp>
         <p:nvSpPr>
-          <p:cNvPr id="3" name="Formel-Fläche"/>
+          <p:cNvPr id="3" name="Formel 09 Fläche Deltoid"/>
           <p:cNvSpPr/>
           <p:nvPr/>
         </p:nvSpPr>
         <p:spPr>
           <a:xfrm>
-            <a:off x="3177540" y="2552700"/>
-            <a:ext cx="5836920" cy="1752600"/>
+            <a:off x="3718560" y="2133600"/>
+            <a:ext cx="4754880" cy="2590800"/>
           </a:xfrm>
           <a:prstGeom prst="roundRect">
             <a:avLst>
-              <a:gd name="adj" fmla="val 15652"/>
+              <a:gd name="adj" fmla="val 12353"/>
             </a:avLst>
           </a:prstGeom>
           <a:solidFill>
@@ -3143,14 +3789,14 @@
       </p:sp>
       <p:sp>
         <p:nvSpPr>
-          <p:cNvPr id="4" name="Formel 09 Deltoid"/>
+          <p:cNvPr id="4" name="Formel 09 Text 1"/>
           <p:cNvSpPr txBox="1"/>
           <p:nvPr/>
         </p:nvSpPr>
         <p:spPr>
           <a:xfrm>
-            <a:off x="3177540" y="2552700"/>
-            <a:ext cx="5836920" cy="1752600"/>
+            <a:off x="4282440" y="2895600"/>
+            <a:ext cx="1712238" cy="1066800"/>
           </a:xfrm>
           <a:prstGeom prst="rect">
             <a:avLst/>
@@ -3159,14 +3805,14 @@
           <a:ln/>
         </p:spPr>
         <p:txBody>
-          <a:bodyPr wrap="square" lIns="0" tIns="0" rIns="0" bIns="0" rtlCol="0" anchor="ctr"/>
+          <a:bodyPr wrap="none" lIns="0" tIns="0" rIns="0" bIns="0" rtlCol="0" anchor="ctr"/>
           <a:lstStyle/>
           <a:p>
             <a:pPr algn="ctr" indent="0" marL="0">
               <a:buNone/>
             </a:pPr>
             <a:r>
-              <a:rPr lang="en-US" sz="6500" b="1" dirty="0">
+              <a:rPr lang="en-US" sz="6000" b="1" dirty="0">
                 <a:solidFill>
                   <a:srgbClr val="8DBBF2"/>
                 </a:solidFill>
@@ -3174,11 +3820,114 @@
                 <a:ea typeface="Poppins" pitchFamily="34" charset="-122"/>
                 <a:cs typeface="Poppins" pitchFamily="34" charset="-120"/>
               </a:rPr>
-              <a:t>A = e · f : 2</a:t>
-            </a:r>
-            <a:endParaRPr lang="en-US" sz="6500" dirty="0"/>
-          </a:p>
-        </p:txBody>
+              <a:t>A = </a:t>
+            </a:r>
+            <a:endParaRPr lang="en-US" sz="6000" dirty="0"/>
+          </a:p>
+        </p:txBody>
+      </p:sp>
+      <p:sp>
+        <p:nvSpPr>
+          <p:cNvPr id="5" name="Formel 09 Text 2"/>
+          <p:cNvSpPr txBox="1"/>
+          <p:nvPr/>
+        </p:nvSpPr>
+        <p:spPr>
+          <a:xfrm>
+            <a:off x="6093738" y="2392680"/>
+            <a:ext cx="1628894" cy="1066800"/>
+          </a:xfrm>
+          <a:prstGeom prst="rect">
+            <a:avLst/>
+          </a:prstGeom>
+          <a:noFill/>
+          <a:ln/>
+        </p:spPr>
+        <p:txBody>
+          <a:bodyPr wrap="none" lIns="0" tIns="0" rIns="0" bIns="0" rtlCol="0" anchor="ctr"/>
+          <a:lstStyle/>
+          <a:p>
+            <a:pPr algn="ctr" indent="0" marL="0">
+              <a:buNone/>
+            </a:pPr>
+            <a:r>
+              <a:rPr lang="en-US" sz="6000" b="1" dirty="0">
+                <a:solidFill>
+                  <a:srgbClr val="8DBBF2"/>
+                </a:solidFill>
+                <a:latin typeface="Poppins" pitchFamily="34" charset="0"/>
+                <a:ea typeface="Poppins" pitchFamily="34" charset="-122"/>
+                <a:cs typeface="Poppins" pitchFamily="34" charset="-120"/>
+              </a:rPr>
+              <a:t>e · f</a:t>
+            </a:r>
+            <a:endParaRPr lang="en-US" sz="6000" dirty="0"/>
+          </a:p>
+        </p:txBody>
+      </p:sp>
+      <p:sp>
+        <p:nvSpPr>
+          <p:cNvPr id="6" name="Formel 09 Text 3"/>
+          <p:cNvSpPr txBox="1"/>
+          <p:nvPr/>
+        </p:nvSpPr>
+        <p:spPr>
+          <a:xfrm>
+            <a:off x="6593681" y="3429000"/>
+            <a:ext cx="629007" cy="1066800"/>
+          </a:xfrm>
+          <a:prstGeom prst="rect">
+            <a:avLst/>
+          </a:prstGeom>
+          <a:noFill/>
+          <a:ln/>
+        </p:spPr>
+        <p:txBody>
+          <a:bodyPr wrap="none" lIns="0" tIns="0" rIns="0" bIns="0" rtlCol="0" anchor="ctr"/>
+          <a:lstStyle/>
+          <a:p>
+            <a:pPr algn="ctr" indent="0" marL="0">
+              <a:buNone/>
+            </a:pPr>
+            <a:r>
+              <a:rPr lang="en-US" sz="6000" b="1" dirty="0">
+                <a:solidFill>
+                  <a:srgbClr val="8DBBF2"/>
+                </a:solidFill>
+                <a:latin typeface="Poppins" pitchFamily="34" charset="0"/>
+                <a:ea typeface="Poppins" pitchFamily="34" charset="-122"/>
+                <a:cs typeface="Poppins" pitchFamily="34" charset="-120"/>
+              </a:rPr>
+              <a:t>2</a:t>
+            </a:r>
+            <a:endParaRPr lang="en-US" sz="6000" dirty="0"/>
+          </a:p>
+        </p:txBody>
+      </p:sp>
+      <p:sp>
+        <p:nvSpPr>
+          <p:cNvPr id="7" name="Formel 09 Bruchstrich"/>
+          <p:cNvSpPr/>
+          <p:nvPr/>
+        </p:nvSpPr>
+        <p:spPr>
+          <a:xfrm>
+            <a:off x="5948958" y="3398520"/>
+            <a:ext cx="1918454" cy="60960"/>
+          </a:xfrm>
+          <a:prstGeom prst="rect">
+            <a:avLst/>
+          </a:prstGeom>
+          <a:solidFill>
+            <a:srgbClr val="8DBBF2"/>
+          </a:solidFill>
+          <a:ln w="12700">
+            <a:solidFill>
+              <a:srgbClr val="8DBBF2"/>
+            </a:solidFill>
+            <a:prstDash val="solid"/>
+          </a:ln>
+        </p:spPr>
       </p:sp>
     </p:spTree>
   </p:cSld>

</xml_diff>